<commit_message>
Initial Commit : AI Finance Tower
</commit_message>
<xml_diff>
--- a/outputs/Finance_Control_Tower.pptx
+++ b/outputs/Finance_Control_Tower.pptx
@@ -3199,7 +3199,7 @@
         </p:nvSpPr>
         <p:spPr>
           <a:xfrm>
-            <a:off x="457200" y="5669280"/>
+            <a:off x="457200" y="6217920"/>
             <a:ext cx="10972800" cy="1005840"/>
           </a:xfrm>
           <a:prstGeom prst="rect">
@@ -3213,14 +3213,19 @@
           </a:bodyPr>
           <a:lstStyle/>
           <a:p>
-            <a:r>
-              <a:t>• Overall AP spend increased by 4.17% in December 2025, driven primarily by Consumer (+5.28%) and Enterprise (+8.27%) units, despite SMB being flat. Consumer spend increased mainly in the East region (35.63%), while Enterprise saw a notable shift with increased spend in the West region (20.29%).</a:t>
-            </a:r>
-          </a:p>
-          <a:p>
-            <a:pPr/>
-            <a:r>
-              <a:t>• Recommended action: Investigate drivers behind Consumer East regional growth and Enterprise West spend uptick for sustainability or risks; consider targeted spend controls or supplier negotiations in these hotspots.</a:t>
+            <a:pPr>
+              <a:defRPr sz="900"/>
+            </a:pPr>
+            <a:r>
+              <a:t>• Spend increased by 4.17% in December 2025, driven mainly by the Consumer and Enterprise units with Consumer spend rising to $102M and Enterprise to $64.3M. Consumer region mix shifted with East region share at 35.6%, indicating higher activity there compared to prior month.</a:t>
+            </a:r>
+          </a:p>
+          <a:p>
+            <a:pPr>
+              <a:defRPr sz="1000"/>
+            </a:pPr>
+            <a:r>
+              <a:t>• SMB spend remained flat at $91.1M but showed a regional shift with North region increasing to 27.85% and South declining to 40.16%, suggesting potential focus areas for cost control. Recommend investigating specific drivers behind Consumer and Enterprise spend growth, particularly East and West regions.</a:t>
             </a:r>
           </a:p>
         </p:txBody>
@@ -3323,7 +3328,7 @@
         </p:nvSpPr>
         <p:spPr>
           <a:xfrm>
-            <a:off x="457200" y="5669280"/>
+            <a:off x="457200" y="6217920"/>
             <a:ext cx="10972800" cy="1005840"/>
           </a:xfrm>
           <a:prstGeom prst="rect">
@@ -3337,14 +3342,19 @@
           </a:bodyPr>
           <a:lstStyle/>
           <a:p>
-            <a:r>
-              <a:t>• Processing time improved by 3.07%, indicating enhanced AP operational efficiency. Late payments decreased further to 27.15%, while dispute rates increased slightly to 6.57%.</a:t>
-            </a:r>
-          </a:p>
-          <a:p>
-            <a:pPr/>
-            <a:r>
-              <a:t>• Recommended action: Continue optimizing process workflows to sustain time gains; address rising disputes through improved vendor communication or dispute resolution mechanisms to prevent escalation.</a:t>
+            <a:pPr>
+              <a:defRPr sz="900"/>
+            </a:pPr>
+            <a:r>
+              <a:t>• Processing time improved by 3.07%, indicating enhanced operational efficiency; late payment percentage dropped significantly to 26.66%, the lowest in the year, which can reduce financial carrying costs.</a:t>
+            </a:r>
+          </a:p>
+          <a:p>
+            <a:pPr>
+              <a:defRPr sz="1000"/>
+            </a:pPr>
+            <a:r>
+              <a:t>• Dispute rate worsened slightly to 7.03%, signaling potential issues with invoice accuracy or vendor disagreements. Recommend focusing on dispute root causes to sustain efficiency gains and further reduce late payments.</a:t>
             </a:r>
           </a:p>
         </p:txBody>
@@ -3383,7 +3393,7 @@
         </p:blipFill>
         <p:spPr>
           <a:xfrm>
-            <a:off x="457200" y="914400"/>
+            <a:off x="457200" y="731520"/>
             <a:ext cx="5486400" cy="2743200"/>
           </a:xfrm>
           <a:prstGeom prst="rect">
@@ -3391,15 +3401,87 @@
           </a:prstGeom>
         </p:spPr>
       </p:pic>
-      <p:sp>
-        <p:nvSpPr>
-          <p:cNvPr id="3" name="TextBox 2"/>
+      <p:pic>
+        <p:nvPicPr>
+          <p:cNvPr id="3" name="Picture 2" descr="ap_s3_pref.png"/>
+          <p:cNvPicPr>
+            <a:picLocks noChangeAspect="1"/>
+          </p:cNvPicPr>
+          <p:nvPr/>
+        </p:nvPicPr>
+        <p:blipFill>
+          <a:blip r:embed="rId3"/>
+          <a:stretch>
+            <a:fillRect/>
+          </a:stretch>
+        </p:blipFill>
+        <p:spPr>
+          <a:xfrm>
+            <a:off x="6400800" y="731520"/>
+            <a:ext cx="5486400" cy="2743200"/>
+          </a:xfrm>
+          <a:prstGeom prst="rect">
+            <a:avLst/>
+          </a:prstGeom>
+        </p:spPr>
+      </p:pic>
+      <p:pic>
+        <p:nvPicPr>
+          <p:cNvPr id="4" name="Picture 3" descr="ap_s3_vendor_cn.png"/>
+          <p:cNvPicPr>
+            <a:picLocks noChangeAspect="1"/>
+          </p:cNvPicPr>
+          <p:nvPr/>
+        </p:nvPicPr>
+        <p:blipFill>
+          <a:blip r:embed="rId4"/>
+          <a:stretch>
+            <a:fillRect/>
+          </a:stretch>
+        </p:blipFill>
+        <p:spPr>
+          <a:xfrm>
+            <a:off x="457200" y="3474720"/>
+            <a:ext cx="5486400" cy="2743200"/>
+          </a:xfrm>
+          <a:prstGeom prst="rect">
+            <a:avLst/>
+          </a:prstGeom>
+        </p:spPr>
+      </p:pic>
+      <p:pic>
+        <p:nvPicPr>
+          <p:cNvPr id="5" name="Picture 4" descr="ap_s3_vendor_cn.png"/>
+          <p:cNvPicPr>
+            <a:picLocks noChangeAspect="1"/>
+          </p:cNvPicPr>
+          <p:nvPr/>
+        </p:nvPicPr>
+        <p:blipFill>
+          <a:blip r:embed="rId4"/>
+          <a:stretch>
+            <a:fillRect/>
+          </a:stretch>
+        </p:blipFill>
+        <p:spPr>
+          <a:xfrm>
+            <a:off x="6400800" y="3474720"/>
+            <a:ext cx="5486400" cy="2743200"/>
+          </a:xfrm>
+          <a:prstGeom prst="rect">
+            <a:avLst/>
+          </a:prstGeom>
+        </p:spPr>
+      </p:pic>
+      <p:sp>
+        <p:nvSpPr>
+          <p:cNvPr id="6" name="TextBox 5"/>
           <p:cNvSpPr txBox="1"/>
           <p:nvPr/>
         </p:nvSpPr>
         <p:spPr>
           <a:xfrm>
-            <a:off x="457200" y="5669280"/>
+            <a:off x="457200" y="6217920"/>
             <a:ext cx="10972800" cy="1005840"/>
           </a:xfrm>
           <a:prstGeom prst="rect">
@@ -3413,14 +3495,19 @@
           </a:bodyPr>
           <a:lstStyle/>
           <a:p>
-            <a:r>
-              <a:t>• Maverick spend increased by 3.06%, indicating growing off-contract purchasing risks. Vendor risk index marginally declined to 27.66, but key vendors maintain high concentration over 64%.</a:t>
-            </a:r>
-          </a:p>
-          <a:p>
-            <a:pPr/>
-            <a:r>
-              <a:t>• Recommended action: Focus on reducing Maverick spend via enhanced policy enforcement and vendor compliance; reassess vendor risk mitigation especially for top five concentrated suppliers to hedge supply chain risks.</a:t>
+            <a:pPr>
+              <a:defRPr sz="900"/>
+            </a:pPr>
+            <a:r>
+              <a:t>• Maverick spend rose sharply by 14.94%, pointing to increased off-contract or unmanaged supplier usage; vendor risk remained stable around 27.66%, showing no immediate heightened risk level.</a:t>
+            </a:r>
+          </a:p>
+          <a:p>
+            <a:pPr>
+              <a:defRPr sz="1000"/>
+            </a:pPr>
+            <a:r>
+              <a:t>• High vendor concentration remains with top 5 vendors each having over 64% concentration, indicating potential single supplier dependencies. Recommend reviewing maverick spend categories and mitigating vendor concentration risks by diversifying suppliers.</a:t>
             </a:r>
           </a:p>
         </p:txBody>
@@ -3467,40 +3554,6 @@
           </a:prstGeom>
         </p:spPr>
       </p:pic>
-      <p:sp>
-        <p:nvSpPr>
-          <p:cNvPr id="3" name="TextBox 2"/>
-          <p:cNvSpPr txBox="1"/>
-          <p:nvPr/>
-        </p:nvSpPr>
-        <p:spPr>
-          <a:xfrm>
-            <a:off x="457200" y="5669280"/>
-            <a:ext cx="10972800" cy="1005840"/>
-          </a:xfrm>
-          <a:prstGeom prst="rect">
-            <a:avLst/>
-          </a:prstGeom>
-          <a:noFill/>
-        </p:spPr>
-        <p:txBody>
-          <a:bodyPr wrap="square">
-            <a:spAutoFit/>
-          </a:bodyPr>
-          <a:lstStyle/>
-          <a:p>
-            <a:r>
-              <a:t>• DPO slightly declined by 0.98%, settling near steady levels, while on-time payment percentage improved notably to 72.85%, implying better working capital management with faster payments.</a:t>
-            </a:r>
-          </a:p>
-          <a:p>
-            <a:pPr/>
-            <a:r>
-              <a:t>• Recommended action: Leverage improved on-time payments to negotiate better vendor terms; monitor DPO trends closely to balance cash flow and supplier relations without compromising payment discipline.</a:t>
-            </a:r>
-          </a:p>
-        </p:txBody>
-      </p:sp>
     </p:spTree>
   </p:cSld>
   <p:clrMapOvr>
@@ -3653,7 +3706,7 @@
         </p:nvSpPr>
         <p:spPr>
           <a:xfrm>
-            <a:off x="457200" y="5669280"/>
+            <a:off x="457200" y="6217920"/>
             <a:ext cx="10972800" cy="1005840"/>
           </a:xfrm>
           <a:prstGeom prst="rect">
@@ -3667,14 +3720,19 @@
           </a:bodyPr>
           <a:lstStyle/>
           <a:p>
-            <a:r>
-              <a:t>• December 2025 showed positive revenue and spend growth but flagged critical concerns in accounts receivable collections and vendor compliance risks. Operational efficiencies in AP improved, yet Maverick spend and dispute rates require attention.</a:t>
-            </a:r>
-          </a:p>
-          <a:p>
-            <a:pPr/>
-            <a:r>
-              <a:t>• Immediate executive focus should be on reversing AR collection collapse, reinforcing AP spend controls especially in high growth regions, and leveraging improved payment timeliness for better working capital. Strengthened vendor risk and compliance programs are essential to mitigate emerging financial risks.</a:t>
+            <a:pPr>
+              <a:defRPr sz="900"/>
+            </a:pPr>
+            <a:r>
+              <a:t>• December 2025 reflects a mixed AP and AR performance with spend growth and operational efficiencies in AP tempered by rising maverick spend and vendor concentration risks. Conversely, AR shows strong revenue gains overshadowed by a critical collapse in collections necessitating urgent remediation.</a:t>
+            </a:r>
+          </a:p>
+          <a:p>
+            <a:pPr>
+              <a:defRPr sz="1000"/>
+            </a:pPr>
+            <a:r>
+              <a:t>• Recommended focus areas include detailed analysis of Consumer and Enterprise spend drivers, aggressive containment of maverick and vendor concentration risk in AP, and immediate enhancement of AR collection practices to prevent cash flow disruptions while leveraging improved payment timeliness.</a:t>
             </a:r>
           </a:p>
         </p:txBody>

</xml_diff>